<commit_message>
Template: Nedgroup theme fonts and colour scheme
</commit_message>
<xml_diff>
--- a/Nedgroup-Investments-template.pptx
+++ b/Nedgroup-Investments-template.pptx
@@ -5633,49 +5633,49 @@
 </file>
 
 <file path=ppt/theme/theme1.xml><?xml version="1.0" encoding="utf-8"?>
-<a:theme xmlns:a="http://schemas.openxmlformats.org/drawingml/2006/main" name="Office Theme">
+<a:theme xmlns:a="http://schemas.openxmlformats.org/drawingml/2006/main" name="Nedgroup Investments">
   <a:themeElements>
     <a:clrScheme name="Office">
       <a:dk1>
-        <a:sysClr val="windowText" lastClr="000000"/>
+        <a:srgbClr val="16211C"/>
       </a:dk1>
       <a:lt1>
-        <a:sysClr val="window" lastClr="FFFFFF"/>
+        <a:srgbClr val="FBFAF7"/>
       </a:lt1>
       <a:dk2>
-        <a:srgbClr val="1F497D"/>
+        <a:srgbClr val="0A3D2B"/>
       </a:dk2>
       <a:lt2>
-        <a:srgbClr val="EEECE1"/>
+        <a:srgbClr val="C3DDD0"/>
       </a:lt2>
       <a:accent1>
-        <a:srgbClr val="4F81BD"/>
+        <a:srgbClr val="0B5138"/>
       </a:accent1>
       <a:accent2>
-        <a:srgbClr val="C0504D"/>
+        <a:srgbClr val="00E677"/>
       </a:accent2>
       <a:accent3>
-        <a:srgbClr val="9BBB59"/>
+        <a:srgbClr val="A8CBB9"/>
       </a:accent3>
       <a:accent4>
-        <a:srgbClr val="8064A2"/>
+        <a:srgbClr val="5D6B63"/>
       </a:accent4>
       <a:accent5>
-        <a:srgbClr val="4BACC6"/>
+        <a:srgbClr val="8B968F"/>
       </a:accent5>
       <a:accent6>
-        <a:srgbClr val="F79646"/>
+        <a:srgbClr val="0A3D2B"/>
       </a:accent6>
       <a:hlink>
-        <a:srgbClr val="0000FF"/>
+        <a:srgbClr val="0B5138"/>
       </a:hlink>
       <a:folHlink>
-        <a:srgbClr val="800080"/>
+        <a:srgbClr val="5D6B63"/>
       </a:folHlink>
     </a:clrScheme>
     <a:fontScheme name="Office">
       <a:majorFont>
-        <a:latin typeface="Calibri"/>
+        <a:latin typeface="Georgia" panose="02040502050405020303"/>
         <a:ea typeface=""/>
         <a:cs typeface=""/>
         <a:font script="Jpan" typeface="ＭＳ Ｐゴシック"/>
@@ -5710,7 +5710,7 @@
         <a:font script="Geor" typeface="Sylfaen"/>
       </a:majorFont>
       <a:minorFont>
-        <a:latin typeface="Calibri"/>
+        <a:latin typeface="Arial" panose="020B0604020202020204"/>
         <a:ea typeface=""/>
         <a:cs typeface=""/>
         <a:font script="Jpan" typeface="ＭＳ Ｐゴシック"/>

</xml_diff>